<commit_message>
Stage 8 review fixes: D-007
</commit_message>
<xml_diff>
--- a/output/archive/Archive/Users/cstrachan_old_laptop/partnerships/2020/Copy of dmpk-handoff-workflow-v2.pptx
+++ b/output/archive/Archive/Users/cstrachan_old_laptop/partnerships/2020/Copy of dmpk-handoff-workflow-v2.pptx
@@ -516,7 +516,7 @@
           <a:lstStyle/>
           <a:p>
             <a:r>
-              <a:t>Working draft for the Quenverell call. The structure is from our old DMPK handoff deck, so the footer and contact slide still need replacing before anything goes to the client.</a:t>
+              <a:t>Working copy for the Quenverell partnership discussion, copied from Merrivoss’s internal DMPK hand-off deck. Source footer and old contact table retained for discussion; refresh before client issue.</a:t>
             </a:r>
           </a:p>
         </p:txBody>
@@ -4157,7 +4157,7 @@
                 </a:solidFill>
                 <a:latin typeface="Arial"/>
               </a:rPr>
-              <a:t>What the partner needs back</a:t>
+              <a:t>What Quenverell needs back</a:t>
             </a:r>
           </a:p>
         </p:txBody>
@@ -4189,7 +4189,7 @@
               <a:rPr sz="2000">
                 <a:latin typeface="Arial"/>
               </a:rPr>
-              <a:t>Measured exposure and clearance for the compounds that were tested, with units stated</a:t>
+              <a:t>Measured exposure and clearance for tested compounds, with matrix, species, route and assay normalisation stated as applicable</a:t>
             </a:r>
           </a:p>
           <a:p>
@@ -5981,7 +5981,7 @@
               <a:rPr sz="2000">
                 <a:latin typeface="Arial"/>
               </a:rPr>
-              <a:t>Score ranking is reliable only within a cluster built on the same receptor model</a:t>
+              <a:t>Compare scores only under consistent model and scoring settings; even within a scaffold cluster, ranking is tentative until checked against experimental evidence</a:t>
             </a:r>
           </a:p>
           <a:p>

</xml_diff>